<commit_message>
Correct typos in cracmm3 emission pdf and ppt mapper
</commit_message>
<xml_diff>
--- a/emissions/cracmm3/cracmm3_mapping_flowchart.pptx
+++ b/emissions/cracmm3/cracmm3_mapping_flowchart.pptx
@@ -124,7 +124,7 @@
   <pc:docChgLst>
     <pc:chgData name="Pye, Havala" userId="9f81b1e5-bd31-4f40-9666-9c20bcecc960" providerId="ADAL" clId="{7A832CE9-27DF-4B19-888A-571C8A750C2B}"/>
     <pc:docChg chg="undo custSel modSld">
-      <pc:chgData name="Pye, Havala" userId="9f81b1e5-bd31-4f40-9666-9c20bcecc960" providerId="ADAL" clId="{7A832CE9-27DF-4B19-888A-571C8A750C2B}" dt="2026-06-08T19:22:19.961" v="829" actId="20577"/>
+      <pc:chgData name="Pye, Havala" userId="9f81b1e5-bd31-4f40-9666-9c20bcecc960" providerId="ADAL" clId="{7A832CE9-27DF-4B19-888A-571C8A750C2B}" dt="2026-06-08T19:53:48.198" v="845" actId="20577"/>
       <pc:docMkLst>
         <pc:docMk/>
       </pc:docMkLst>
@@ -319,7 +319,7 @@
         </pc:spChg>
       </pc:sldChg>
       <pc:sldChg chg="addSp delSp modSp mod">
-        <pc:chgData name="Pye, Havala" userId="9f81b1e5-bd31-4f40-9666-9c20bcecc960" providerId="ADAL" clId="{7A832CE9-27DF-4B19-888A-571C8A750C2B}" dt="2026-06-08T19:14:15.613" v="590" actId="13926"/>
+        <pc:chgData name="Pye, Havala" userId="9f81b1e5-bd31-4f40-9666-9c20bcecc960" providerId="ADAL" clId="{7A832CE9-27DF-4B19-888A-571C8A750C2B}" dt="2026-06-08T19:53:48.198" v="845" actId="20577"/>
         <pc:sldMkLst>
           <pc:docMk/>
           <pc:sldMk cId="2899913161" sldId="260"/>
@@ -389,7 +389,7 @@
           </ac:spMkLst>
         </pc:spChg>
         <pc:spChg chg="mod">
-          <ac:chgData name="Pye, Havala" userId="9f81b1e5-bd31-4f40-9666-9c20bcecc960" providerId="ADAL" clId="{7A832CE9-27DF-4B19-888A-571C8A750C2B}" dt="2026-06-08T19:13:35.518" v="564"/>
+          <ac:chgData name="Pye, Havala" userId="9f81b1e5-bd31-4f40-9666-9c20bcecc960" providerId="ADAL" clId="{7A832CE9-27DF-4B19-888A-571C8A750C2B}" dt="2026-06-08T19:53:48.198" v="845" actId="20577"/>
           <ac:spMkLst>
             <pc:docMk/>
             <pc:sldMk cId="2899913161" sldId="260"/>
@@ -397,7 +397,7 @@
           </ac:spMkLst>
         </pc:spChg>
         <pc:spChg chg="mod">
-          <ac:chgData name="Pye, Havala" userId="9f81b1e5-bd31-4f40-9666-9c20bcecc960" providerId="ADAL" clId="{7A832CE9-27DF-4B19-888A-571C8A750C2B}" dt="2026-06-08T19:13:29.469" v="563" actId="20577"/>
+          <ac:chgData name="Pye, Havala" userId="9f81b1e5-bd31-4f40-9666-9c20bcecc960" providerId="ADAL" clId="{7A832CE9-27DF-4B19-888A-571C8A750C2B}" dt="2026-06-08T19:53:44.525" v="839" actId="20577"/>
           <ac:spMkLst>
             <pc:docMk/>
             <pc:sldMk cId="2899913161" sldId="260"/>
@@ -542,7 +542,7 @@
         </pc:cxnChg>
       </pc:sldChg>
       <pc:sldChg chg="addSp delSp modSp mod">
-        <pc:chgData name="Pye, Havala" userId="9f81b1e5-bd31-4f40-9666-9c20bcecc960" providerId="ADAL" clId="{7A832CE9-27DF-4B19-888A-571C8A750C2B}" dt="2026-06-08T19:07:09.774" v="443" actId="14100"/>
+        <pc:chgData name="Pye, Havala" userId="9f81b1e5-bd31-4f40-9666-9c20bcecc960" providerId="ADAL" clId="{7A832CE9-27DF-4B19-888A-571C8A750C2B}" dt="2026-06-08T19:53:37.181" v="833" actId="6549"/>
         <pc:sldMkLst>
           <pc:docMk/>
           <pc:sldMk cId="1988119278" sldId="261"/>
@@ -572,7 +572,7 @@
           </ac:spMkLst>
         </pc:spChg>
         <pc:spChg chg="mod">
-          <ac:chgData name="Pye, Havala" userId="9f81b1e5-bd31-4f40-9666-9c20bcecc960" providerId="ADAL" clId="{7A832CE9-27DF-4B19-888A-571C8A750C2B}" dt="2026-06-08T19:06:51.495" v="436" actId="1076"/>
+          <ac:chgData name="Pye, Havala" userId="9f81b1e5-bd31-4f40-9666-9c20bcecc960" providerId="ADAL" clId="{7A832CE9-27DF-4B19-888A-571C8A750C2B}" dt="2026-06-08T19:53:37.181" v="833" actId="6549"/>
           <ac:spMkLst>
             <pc:docMk/>
             <pc:sldMk cId="1988119278" sldId="261"/>
@@ -9653,7 +9653,7 @@
                   <a:srgbClr val="FFFF00"/>
                 </a:highlight>
               </a:rPr>
-              <a:t>Is the compound and </a:t>
+              <a:t>Is the compound </a:t>
             </a:r>
             <a:r>
               <a:rPr lang="en-US" sz="1000" dirty="0" err="1">
@@ -13468,7 +13468,7 @@
           <a:p>
             <a:r>
               <a:rPr lang="en-US" sz="1000" dirty="0"/>
-              <a:t>Alkane-like IVOCs of highest volatility (VROCP6ALK)</a:t>
+              <a:t>Else: Alkane-like IVOCs of highest volatility (VROCP6ALK)</a:t>
             </a:r>
           </a:p>
         </p:txBody>
@@ -13677,7 +13677,7 @@
           <a:p>
             <a:r>
               <a:rPr lang="en-US" sz="1000" dirty="0"/>
-              <a:t>Alkane-like IVOCs of intermediate volatility (VROCP5ALK)</a:t>
+              <a:t>Else: Alkane-like IVOCs of intermediate volatility (VROCP5ALK)</a:t>
             </a:r>
           </a:p>
         </p:txBody>

</xml_diff>